<commit_message>
docs(pptx): update progress report presentation with latest multi-signal AI Stylist and combo card achievements
</commit_message>
<xml_diff>
--- a/BaoCao_TienDo_DATN_N&B_Fashion.pptx
+++ b/BaoCao_TienDo_DATN_N&B_Fashion.pptx
@@ -4784,7 +4784,7 @@
               </a:defRPr>
             </a:pPr>
             <a:r>
-              <a:t>2. GỢI Ý SIZE CƠ THỂ THÔNG MINH (AI RECOMMENDATION)</a:t>
+              <a:t>2. TRỢ LÝ AI STYLIST &amp; COMBO CÁ NHÂN HÓA (GEMINI LLM)</a:t>
             </a:r>
           </a:p>
           <a:p>
@@ -4796,7 +4796,7 @@
               </a:defRPr>
             </a:pPr>
             <a:r>
-              <a:t>• Khách chỉ cần nhập Chiều cao &amp; Cân nặng (hoặc số đo 3 vòng: ngực, eo, mông).</a:t>
+              <a:t>• Tích hợp Chatbox AI Stylist độc quyền, kết nối mô hình ngôn ngữ lớn Google Gemini.</a:t>
             </a:r>
           </a:p>
           <a:p>
@@ -4808,7 +4808,7 @@
               </a:defRPr>
             </a:pPr>
             <a:r>
-              <a:t>• Thuật toán nhân trắc học tự động ước lượng và so khớp bảng size thực tế của hãng.</a:t>
+              <a:t>• Cá nhân hóa đa nguồn: Số đo nhân trắc + Lịch sử tìm kiếm gần nhất + Lịch sử đơn hàng đã đặt (phối chéo tủ đồ cũ).</a:t>
             </a:r>
           </a:p>
           <a:p>
@@ -4820,7 +4820,7 @@
               </a:defRPr>
             </a:pPr>
             <a:r>
-              <a:t>• Tự động gắn huy hiệu 'Gợi ý cho bạn: Size M' ngay trên giao diện đặt hàng.</a:t>
+              <a:t>• Tự động sinh Thẻ Combo Mua Sắm Thương Mại (Áo + Quần) với ảnh thật, giá thật, 1 nút 'Thêm giỏ' &amp; 'Mua ngay'.</a:t>
             </a:r>
           </a:p>
         </p:txBody>
@@ -5776,7 +5776,7 @@
               </a:defRPr>
             </a:pPr>
             <a:r>
-              <a:t>KỊCH BẢN 1: KHÁCH HÀNG</a:t>
+              <a:t>KỊCH BẢN 1: KHÁCH HÀNG &amp; AI STYLIST</a:t>
             </a:r>
           </a:p>
           <a:p>
@@ -5788,7 +5788,7 @@
               </a:defRPr>
             </a:pPr>
             <a:r>
-              <a:t>1. Truy cập trang chủ N&amp;B &amp; Danh mục sản phẩm (55 sản phẩm).</a:t>
+              <a:t>1. Mở Chatbox AI Stylist -&gt; Nhận tư vấn cá nhân hóa theo số đo, lịch sử tìm kiếm &amp; đơn hàng cũ.</a:t>
             </a:r>
           </a:p>
           <a:p>
@@ -5800,7 +5800,7 @@
               </a:defRPr>
             </a:pPr>
             <a:r>
-              <a:t>2. Nhập số đo chiều cao/cân nặng tại trang Tài khoản.</a:t>
+              <a:t>2. Nhận Thẻ Combo Mua Sắm trực quan -&gt; Bấm 'Thêm vào giỏ' hoặc 'Mua ngay' 1-chạm.</a:t>
             </a:r>
           </a:p>
           <a:p>
@@ -5812,7 +5812,7 @@
               </a:defRPr>
             </a:pPr>
             <a:r>
-              <a:t>3. Vào xem chi tiết Áo sơ mi / Áo thun -&gt; Thấy huy hiệu gợi ý size M.</a:t>
+              <a:t>3. Truy cập Phòng thử đồ 3D -&gt; Trải nghiệm xoay 360 độ, kiểm tra độ rủ vải và thẻ Fit Card.</a:t>
             </a:r>
           </a:p>
           <a:p>
@@ -5824,7 +5824,7 @@
               </a:defRPr>
             </a:pPr>
             <a:r>
-              <a:t>4. Bấm 'Thử đồ 3D' -&gt; Trải nghiệm xoay lật 360 độ và đổi màu áo.</a:t>
+              <a:t>4. Đặt hàng qua COD hoặc quét mã VietQR tự động với sổ địa chỉ nhận hàng.</a:t>
             </a:r>
           </a:p>
           <a:p>
@@ -5836,7 +5836,7 @@
               </a:defRPr>
             </a:pPr>
             <a:r>
-              <a:t>5. Đặt hàng qua COD với sổ địa chỉ nhận hàng.</a:t>
+              <a:t>5. Quy trình khép kín: Tư vấn AI -&gt; Thử đồ 3D -&gt; Mua hàng chỉ trong vài thao tác.</a:t>
             </a:r>
           </a:p>
         </p:txBody>
@@ -6311,19 +6311,24 @@
               </a:defRPr>
             </a:pPr>
             <a:r>
+              <a:t>✔ Đột phá AI Stylist: Tích hợp Gemini LLM gợi ý combo cá nhân hóa theo số đo, lịch sử tìm kiếm &amp; đơn hàng cũ.</a:t>
+            </a:r>
+          </a:p>
+          <a:p>
+            <a:pPr>
+              <a:defRPr sz="1300">
+                <a:solidFill>
+                  <a:srgbClr val="6B7280"/>
+                </a:solidFill>
+              </a:defRPr>
+            </a:pPr>
+            <a:r>
               <a:t>✔ Tích hợp thành công API thật của bưu cục Giao Hàng Nhanh (GHN) và module in phiếu đóng hàng bưu điện.</a:t>
             </a:r>
           </a:p>
           <a:p>
-            <a:pPr>
-              <a:defRPr sz="1300">
-                <a:solidFill>
-                  <a:srgbClr val="6B7280"/>
-                </a:solidFill>
-              </a:defRPr>
-            </a:pPr>
-            <a:r>
-              <a:t>✔ Bộ kiểm thử tự động toàn diện: 78 backend pytest, 60 node test, 65 vitest UI đều pass 100%.</a:t>
+            <a:r>
+              <a:t>✔ Bộ kiểm thử tự động toàn diện: 78 backend pytest, 60 node integration tests, 70 vitest UI tests đều pass 100%.</a:t>
             </a:r>
           </a:p>
         </p:txBody>

</xml_diff>